<commit_message>
docs: shift Challenge dates to 19 Oct–20 Nov
Start later, add an application cutoff, stretch the test tour, and move idea review and the final show to November.

Co-authored-by: Cursor <cursoragent@cursor.com>
</commit_message>
<xml_diff>
--- a/AI Challenge.pptx
+++ b/AI Challenge.pptx
@@ -3462,7 +3462,7 @@
                 <a:ea typeface="Arial"/>
                 <a:cs typeface="Arial"/>
               </a:rPr>
-              <a:t>8 октября — 11 ноября</a:t>
+              <a:t>19 октября — 20 ноября</a:t>
             </a:r>
           </a:p>
         </p:txBody>
@@ -3999,7 +3999,7 @@
                 <a:ea typeface="Arial"/>
                 <a:cs typeface="Arial"/>
               </a:rPr>
-              <a:t>9 октября</a:t>
+              <a:t>20 октября</a:t>
             </a:r>
           </a:p>
         </p:txBody>
@@ -4245,7 +4245,7 @@
                 <a:ea typeface="Arial"/>
                 <a:cs typeface="Arial"/>
               </a:rPr>
-              <a:t>12–16 октября</a:t>
+              <a:t>до 21 октября</a:t>
             </a:r>
           </a:p>
         </p:txBody>
@@ -4284,7 +4284,7 @@
                 <a:ea typeface="Uncage"/>
                 <a:cs typeface="Uncage"/>
               </a:rPr>
-              <a:t>Практика</a:t>
+              <a:t>Заявки</a:t>
             </a:r>
           </a:p>
         </p:txBody>
@@ -4323,7 +4323,7 @@
                 <a:ea typeface="Arial"/>
                 <a:cs typeface="Arial"/>
               </a:rPr>
-              <a:t>Собираем свой минипроцесс в Битриксе на тестовом стенде, пока без агентов</a:t>
+              <a:t>Подаёте заявку на участие</a:t>
             </a:r>
           </a:p>
         </p:txBody>
@@ -4491,7 +4491,7 @@
                 <a:ea typeface="Arial"/>
                 <a:cs typeface="Arial"/>
               </a:rPr>
-              <a:t>19–26 октября</a:t>
+              <a:t>22–30 октября</a:t>
             </a:r>
           </a:p>
         </p:txBody>
@@ -4530,7 +4530,7 @@
                 <a:ea typeface="Uncage"/>
                 <a:cs typeface="Uncage"/>
               </a:rPr>
-              <a:t>Идея</a:t>
+              <a:t>Тестовый тур</a:t>
             </a:r>
           </a:p>
         </p:txBody>
@@ -4569,7 +4569,7 @@
                 <a:ea typeface="Arial"/>
                 <a:cs typeface="Arial"/>
               </a:rPr>
-              <a:t>Кто прошёл в общий тур, готовит идею для челленджа</a:t>
+              <a:t>Задания выдаём 22 октября. Собираем минипроцесс в Битриксе на тестовом стенде, без агентов</a:t>
             </a:r>
           </a:p>
         </p:txBody>
@@ -4737,7 +4737,7 @@
                 <a:ea typeface="Arial"/>
                 <a:cs typeface="Arial"/>
               </a:rPr>
-              <a:t>26 октября</a:t>
+              <a:t>6 ноября</a:t>
             </a:r>
           </a:p>
         </p:txBody>
@@ -4776,7 +4776,7 @@
                 <a:ea typeface="Uncage"/>
                 <a:cs typeface="Uncage"/>
               </a:rPr>
-              <a:t>Представление идей и отбор</a:t>
+              <a:t>Просмотр идей</a:t>
             </a:r>
           </a:p>
         </p:txBody>
@@ -4983,7 +4983,7 @@
                 <a:ea typeface="Arial"/>
                 <a:cs typeface="Arial"/>
               </a:rPr>
-              <a:t>27 октября — 10 ноября</a:t>
+              <a:t>7–19 ноября</a:t>
             </a:r>
           </a:p>
         </p:txBody>
@@ -5229,7 +5229,7 @@
                 <a:ea typeface="Arial"/>
                 <a:cs typeface="Arial"/>
               </a:rPr>
-              <a:t>11 ноября</a:t>
+              <a:t>20 ноября</a:t>
             </a:r>
           </a:p>
         </p:txBody>
@@ -5268,7 +5268,7 @@
                 <a:ea typeface="Uncage"/>
                 <a:cs typeface="Uncage"/>
               </a:rPr>
-              <a:t>Демодень</a:t>
+              <a:t>Показ</a:t>
             </a:r>
           </a:p>
         </p:txBody>
@@ -5800,7 +5800,7 @@
                 <a:ea typeface="Arial"/>
                 <a:cs typeface="Arial"/>
               </a:rPr>
-              <a:t>9 октября</a:t>
+              <a:t>20 октября</a:t>
             </a:r>
           </a:p>
         </p:txBody>
@@ -6007,7 +6007,7 @@
                 <a:ea typeface="Uncage"/>
                 <a:cs typeface="Uncage"/>
               </a:rPr>
-              <a:t>Практика</a:t>
+              <a:t>Заявки</a:t>
             </a:r>
           </a:p>
         </p:txBody>
@@ -6046,7 +6046,7 @@
                 <a:ea typeface="Arial"/>
                 <a:cs typeface="Arial"/>
               </a:rPr>
-              <a:t>12–16 октября</a:t>
+              <a:t>до 21 октября</a:t>
             </a:r>
           </a:p>
         </p:txBody>
@@ -6085,7 +6085,7 @@
                 <a:ea typeface="Arial"/>
                 <a:cs typeface="Arial"/>
               </a:rPr>
-              <a:t>Каждый собирает свой минипроцесс в Битриксе на тестовом стенде. На этом шаге работаем без агентов.</a:t>
+              <a:t>Подаёте заявку на участие. Без заявки в тестовый тур не выходим.</a:t>
             </a:r>
           </a:p>
         </p:txBody>
@@ -6253,7 +6253,7 @@
                 <a:ea typeface="Uncage"/>
                 <a:cs typeface="Uncage"/>
               </a:rPr>
-              <a:t>Идея</a:t>
+              <a:t>Тестовый тур</a:t>
             </a:r>
           </a:p>
         </p:txBody>
@@ -6292,7 +6292,7 @@
                 <a:ea typeface="Arial"/>
                 <a:cs typeface="Arial"/>
               </a:rPr>
-              <a:t>19–26 октября</a:t>
+              <a:t>22–30 октября</a:t>
             </a:r>
           </a:p>
         </p:txBody>
@@ -6331,7 +6331,7 @@
                 <a:ea typeface="Arial"/>
                 <a:cs typeface="Arial"/>
               </a:rPr>
-              <a:t>Выбираете процесс и предлагаете, как выстроить его иначе. Можно свой, кросс-функциональный или чужой — если понимаете, как он устроен.</a:t>
+              <a:t>22 октября выдаём задания. Каждый собирает свой минипроцесс в Битриксе на тестовом стенде, без агентов.</a:t>
             </a:r>
           </a:p>
         </p:txBody>
@@ -6499,7 +6499,7 @@
                 <a:ea typeface="Uncage"/>
                 <a:cs typeface="Uncage"/>
               </a:rPr>
-              <a:t>Представление идей</a:t>
+              <a:t>Просмотр идей</a:t>
             </a:r>
           </a:p>
         </p:txBody>
@@ -6538,7 +6538,7 @@
                 <a:ea typeface="Arial"/>
                 <a:cs typeface="Arial"/>
               </a:rPr>
-              <a:t>26 октября</a:t>
+              <a:t>6 ноября</a:t>
             </a:r>
           </a:p>
         </p:txBody>
@@ -6784,7 +6784,7 @@
                 <a:ea typeface="Arial"/>
                 <a:cs typeface="Arial"/>
               </a:rPr>
-              <a:t>27 октября — 10 ноября</a:t>
+              <a:t>7–19 ноября</a:t>
             </a:r>
           </a:p>
         </p:txBody>
@@ -6991,7 +6991,7 @@
                 <a:ea typeface="Uncage"/>
                 <a:cs typeface="Uncage"/>
               </a:rPr>
-              <a:t>Демодень</a:t>
+              <a:t>Показ</a:t>
             </a:r>
           </a:p>
         </p:txBody>
@@ -7030,7 +7030,7 @@
                 <a:ea typeface="Arial"/>
                 <a:cs typeface="Arial"/>
               </a:rPr>
-              <a:t>11 ноября</a:t>
+              <a:t>20 ноября</a:t>
             </a:r>
           </a:p>
         </p:txBody>
@@ -7214,7 +7214,7 @@
                 <a:ea typeface="Arial"/>
                 <a:cs typeface="Arial"/>
               </a:rPr>
-              <a:t>Этап идея · 19–26 октября</a:t>
+              <a:t>Просмотр идей · 6 ноября</a:t>
             </a:r>
           </a:p>
         </p:txBody>
@@ -9473,7 +9473,7 @@
                 <a:ea typeface="Arial"/>
                 <a:cs typeface="Arial"/>
               </a:rPr>
-              <a:t>Demo Day · 11 ноября</a:t>
+              <a:t>Показ · 20 ноября</a:t>
             </a:r>
           </a:p>
         </p:txBody>
@@ -11946,7 +11946,7 @@
                 <a:ea typeface="Arial"/>
                 <a:cs typeface="Arial"/>
               </a:rPr>
-              <a:t>Demo Day · 11 ноября</a:t>
+              <a:t>Показ · 20 ноября</a:t>
             </a:r>
           </a:p>
         </p:txBody>
@@ -13072,7 +13072,7 @@
                 <a:ea typeface="Arial"/>
                 <a:cs typeface="Arial"/>
               </a:rPr>
-              <a:t>Официальное объявление — 8 октября. Демодень — 11 ноября.</a:t>
+              <a:t>Старт — 19 октября. Показ — 20 ноября.</a:t>
             </a:r>
           </a:p>
         </p:txBody>
@@ -13189,7 +13189,7 @@
                           <a:ea typeface="Arial"/>
                           <a:cs typeface="Arial"/>
                         </a:rPr>
-                        <a:t>Объявление</a:t>
+                        <a:t>Начало</a:t>
                       </a:r>
                     </a:p>
                   </a:txBody>
@@ -13213,7 +13213,7 @@
                           <a:ea typeface="Arial"/>
                           <a:cs typeface="Arial"/>
                         </a:rPr>
-                        <a:t>8 октября</a:t>
+                        <a:t>19 октября</a:t>
                       </a:r>
                     </a:p>
                   </a:txBody>
@@ -13287,7 +13287,7 @@
                           <a:ea typeface="Arial"/>
                           <a:cs typeface="Arial"/>
                         </a:rPr>
-                        <a:t>9 октября</a:t>
+                        <a:t>20 октября</a:t>
                       </a:r>
                     </a:p>
                   </a:txBody>
@@ -13337,7 +13337,7 @@
                           <a:ea typeface="Arial"/>
                           <a:cs typeface="Arial"/>
                         </a:rPr>
-                        <a:t>Тестовое задание</a:t>
+                        <a:t>Сбор заявок</a:t>
                       </a:r>
                     </a:p>
                   </a:txBody>
@@ -13361,7 +13361,7 @@
                           <a:ea typeface="Arial"/>
                           <a:cs typeface="Arial"/>
                         </a:rPr>
-                        <a:t>12–16 октября</a:t>
+                        <a:t>до 21 октября</a:t>
                       </a:r>
                     </a:p>
                   </a:txBody>
@@ -13385,7 +13385,7 @@
                           <a:ea typeface="Arial"/>
                           <a:cs typeface="Arial"/>
                         </a:rPr>
-                        <a:t>Свой минипроцесс в Битриксе на тестовом стенде, без агентов</a:t>
+                        <a:t>Заявка на участие</a:t>
                       </a:r>
                     </a:p>
                   </a:txBody>
@@ -13411,7 +13411,7 @@
                           <a:ea typeface="Arial"/>
                           <a:cs typeface="Arial"/>
                         </a:rPr>
-                        <a:t>Общий тур</a:t>
+                        <a:t>Выдача заданий</a:t>
                       </a:r>
                     </a:p>
                   </a:txBody>
@@ -13435,7 +13435,7 @@
                           <a:ea typeface="Arial"/>
                           <a:cs typeface="Arial"/>
                         </a:rPr>
-                        <a:t>19 октября</a:t>
+                        <a:t>22 октября</a:t>
                       </a:r>
                     </a:p>
                   </a:txBody>
@@ -13459,7 +13459,7 @@
                           <a:ea typeface="Arial"/>
                           <a:cs typeface="Arial"/>
                         </a:rPr>
-                        <a:t>Объявление тех, кто идёт дальше</a:t>
+                        <a:t>Задания тестового тура</a:t>
                       </a:r>
                     </a:p>
                   </a:txBody>
@@ -13485,7 +13485,7 @@
                           <a:ea typeface="Arial"/>
                           <a:cs typeface="Arial"/>
                         </a:rPr>
-                        <a:t>Подготовка идей</a:t>
+                        <a:t>Тестовый тур</a:t>
                       </a:r>
                     </a:p>
                   </a:txBody>
@@ -13509,7 +13509,7 @@
                           <a:ea typeface="Arial"/>
                           <a:cs typeface="Arial"/>
                         </a:rPr>
-                        <a:t>19–26 октября</a:t>
+                        <a:t>до 30 октября</a:t>
                       </a:r>
                     </a:p>
                   </a:txBody>
@@ -13533,7 +13533,7 @@
                           <a:ea typeface="Arial"/>
                           <a:cs typeface="Arial"/>
                         </a:rPr>
-                        <a:t>Описание процесса, идеи и ожидаемого эффекта</a:t>
+                        <a:t>Минипроцесс в Битриксе на тестовом стенде, без агентов</a:t>
                       </a:r>
                     </a:p>
                   </a:txBody>
@@ -13559,7 +13559,7 @@
                           <a:ea typeface="Arial"/>
                           <a:cs typeface="Arial"/>
                         </a:rPr>
-                        <a:t>Представление идей</a:t>
+                        <a:t>Просмотр идей</a:t>
                       </a:r>
                     </a:p>
                   </a:txBody>
@@ -13583,7 +13583,7 @@
                           <a:ea typeface="Arial"/>
                           <a:cs typeface="Arial"/>
                         </a:rPr>
-                        <a:t>26 октября</a:t>
+                        <a:t>6 ноября</a:t>
                       </a:r>
                     </a:p>
                   </a:txBody>
@@ -13657,7 +13657,7 @@
                           <a:ea typeface="Arial"/>
                           <a:cs typeface="Arial"/>
                         </a:rPr>
-                        <a:t>27 октября — 10 ноября</a:t>
+                        <a:t>7–19 ноября</a:t>
                       </a:r>
                     </a:p>
                   </a:txBody>
@@ -13707,7 +13707,7 @@
                           <a:ea typeface="Arial"/>
                           <a:cs typeface="Arial"/>
                         </a:rPr>
-                        <a:t>Демодень</a:t>
+                        <a:t>Показ</a:t>
                       </a:r>
                     </a:p>
                   </a:txBody>
@@ -13731,7 +13731,7 @@
                           <a:ea typeface="Arial"/>
                           <a:cs typeface="Arial"/>
                         </a:rPr>
-                        <a:t>11 ноября</a:t>
+                        <a:t>20 ноября</a:t>
                       </a:r>
                     </a:p>
                   </a:txBody>

</xml_diff>

<commit_message>
fix: keep applications open until 22 October at noon
Colleagues can still apply tomorrow until 12:00 MSK; the public form, cloud API and reglament now use the same deadline.

Co-authored-by: Cursor <cursoragent@cursor.com>
</commit_message>
<xml_diff>
--- a/AI Challenge.pptx
+++ b/AI Challenge.pptx
@@ -4245,7 +4245,7 @@
                 <a:ea typeface="Arial"/>
                 <a:cs typeface="Arial"/>
               </a:rPr>
-              <a:t>до 21 октября</a:t>
+              <a:t>до 22 октября, 12:00</a:t>
             </a:r>
           </a:p>
         </p:txBody>
@@ -6046,7 +6046,7 @@
                 <a:ea typeface="Arial"/>
                 <a:cs typeface="Arial"/>
               </a:rPr>
-              <a:t>до 21 октября</a:t>
+              <a:t>до 22 октября, 12:00</a:t>
             </a:r>
           </a:p>
         </p:txBody>
@@ -13361,7 +13361,7 @@
                           <a:ea typeface="Arial"/>
                           <a:cs typeface="Arial"/>
                         </a:rPr>
-                        <a:t>до 21 октября</a:t>
+                        <a:t>до 22 октября, 12:00</a:t>
                       </a:r>
                     </a:p>
                   </a:txBody>

</xml_diff>